<commit_message>
docs: rapport PowerPoint présenté comme un travail individuel
- page de garde : nom, prénom et matricule de l'auteur, encart « Travail individuel »
  avec les chiffres clés, à la place de la liste des membres
- diapositive 19 : organisation du travail personnel par phases
- suppression de toute tournure collective (« notre », « membres », « tous »)
</commit_message>
<xml_diff>
--- a/rapport/rapport_projet3.pptx
+++ b/rapport/rapport_projet3.pptx
@@ -126,7 +126,7 @@
   <p:extLst>
     <p:ext uri="{521415D9-36F7-43E2-AB2F-B90AF26B5E84}">
       <p14:sectionLst xmlns:p14="http://schemas.microsoft.com/office/powerpoint/2010/main">
-        <p14:section name="Présentation" id="{64c83ade-14ca-0895-272b-c188b455a6f5}">
+        <p14:section name="Présentation" id="{1e614cd5-89f3-dc59-547f-2ab3155366e5}">
           <p14:sldIdLst>
             <p14:sldId id="256"/>
             <p14:sldId id="257"/>
@@ -134,14 +134,14 @@
             <p14:sldId id="259"/>
           </p14:sldIdLst>
         </p14:section>
-        <p14:section name="Conception" id="{201854db-e52b-f607-28e0-37dc84836bce}">
+        <p14:section name="Conception" id="{bdfdacb9-c326-26b3-175d-6659ecf5cdb6}">
           <p14:sldIdLst>
             <p14:sldId id="260"/>
             <p14:sldId id="261"/>
             <p14:sldId id="262"/>
           </p14:sldIdLst>
         </p14:section>
-        <p14:section name="Réalisations" id="{e9daa13f-b732-6731-abe4-013015ea2b43}">
+        <p14:section name="Réalisations" id="{61df51f5-c4a1-30ad-9b62-5354ce142889}">
           <p14:sldIdLst>
             <p14:sldId id="263"/>
             <p14:sldId id="264"/>
@@ -151,7 +151,7 @@
             <p14:sldId id="268"/>
           </p14:sldIdLst>
         </p14:section>
-        <p14:section name="Qualité" id="{b9b62fd4-1f98-537b-6ffc-e6816ea8b699}">
+        <p14:section name="Qualité" id="{36159f3b-1dd2-f41f-b378-3e780fcb8f5d}">
           <p14:sldIdLst>
             <p14:sldId id="269"/>
             <p14:sldId id="270"/>
@@ -159,7 +159,7 @@
             <p14:sldId id="272"/>
           </p14:sldIdLst>
         </p14:section>
-        <p14:section name="Bilan" id="{91711f71-8e5b-aef5-5bdd-54f427621080}">
+        <p14:section name="Bilan" id="{0fdfaffc-1f1e-9391-ee49-dd9f586e7045}">
           <p14:sldIdLst>
             <p14:sldId id="273"/>
             <p14:sldId id="274"/>
@@ -570,7 +570,7 @@
           <a:p>
             <a:r>
               <a:rPr lang="en-US" dirty="0"/>
-              <a:t>Page de garde. Compléter le nom du groupe, la filière et le niveau, et la liste des membres (nom, prénom, matricule, rôle).</a:t>
+              <a:t>Page de garde d'un travail individuel. Compléter le nom, le prénom, le matricule, la filière et le niveau.</a:t>
             </a:r>
             <a:endParaRPr lang="en-US" dirty="0"/>
           </a:p>
@@ -1450,7 +1450,7 @@
           <a:p>
             <a:r>
               <a:rPr lang="en-US" dirty="0"/>
-              <a:t>Compléter avec les vrais noms. Chaque étape a été précédée d'une spécification et d'un plan (dossier docs/), puis d'un commit clair.</a:t>
+              <a:t>Projet réalisé seul, de l'analyse du sujet au rendu. Chaque étape de développement a été précédée d'une spécification et d'un plan (dossier docs/), puis d'un commit clair.</a:t>
             </a:r>
             <a:endParaRPr lang="en-US" dirty="0"/>
           </a:p>
@@ -1538,7 +1538,7 @@
           <a:p>
             <a:r>
               <a:rPr lang="en-US" dirty="0"/>
-              <a:t>Le lycée calcule les moyennes sur des feuilles de calcul et les parents doivent se déplacer pour connaître les résultats. Notre portail centralise les notes et rend chaque bulletin consultable en ligne.</a:t>
+              <a:t>Le lycée calcule les moyennes sur des feuilles de calcul et les parents doivent se déplacer pour connaître les résultats. Le portail réalisé centralise les notes et rend chaque bulletin consultable en ligne.</a:t>
             </a:r>
             <a:endParaRPr lang="en-US" dirty="0"/>
           </a:p>
@@ -3107,7 +3107,7 @@
                   <a:schemeClr val="accent6"/>
                 </a:solidFill>
               </a:rPr>
-              <a:t>Rapport de projet — évaluation finale</a:t>
+              <a:t>Rapport de projet individuel — évaluation finale</a:t>
             </a:r>
             <a:endParaRPr lang="en-US" sz="1800" dirty="0"/>
           </a:p>
@@ -3128,7 +3128,7 @@
           </p:nvPr>
         </p:nvGraphicFramePr>
         <p:xfrm>
-          <a:off x="548640" y="3840480"/>
+          <a:off x="548640" y="3749040"/>
           <a:ext cx="5852160" cy="914400"/>
         </p:xfrm>
         <a:graphic>
@@ -3154,7 +3154,77 @@
                             <a:srgbClr val="94A3B8"/>
                           </a:solidFill>
                         </a:rPr>
-                        <a:t>Groupe</a:t>
+                        <a:t>Nom et prénom</a:t>
+                      </a:r>
+                      <a:endParaRPr lang="en-US" sz="1300" dirty="0"/>
+                    </a:p>
+                  </a:txBody>
+                  <a:tcPr marL="0" marR="0" marT="0" marB="0">
+                    <a:lnL w="0" cap="flat" cmpd="sng" algn="ctr">
+                      <a:noFill/>
+                    </a:lnL>
+                    <a:lnR w="0" cap="flat" cmpd="sng" algn="ctr">
+                      <a:noFill/>
+                    </a:lnR>
+                    <a:lnT w="0" cap="flat" cmpd="sng" algn="ctr">
+                      <a:noFill/>
+                    </a:lnT>
+                    <a:lnB w="0" cap="flat" cmpd="sng" algn="ctr">
+                      <a:noFill/>
+                    </a:lnB>
+                  </a:tcPr>
+                </a:tc>
+                <a:tc>
+                  <a:txBody>
+                    <a:bodyPr/>
+                    <a:lstStyle/>
+                    <a:p>
+                      <a:pPr indent="0" marL="0">
+                        <a:buNone/>
+                      </a:pPr>
+                      <a:r>
+                        <a:rPr lang="en-US" sz="1400" b="1" dirty="0">
+                          <a:solidFill>
+                            <a:srgbClr val="FFFFFF"/>
+                          </a:solidFill>
+                        </a:rPr>
+                        <a:t>[À compléter]</a:t>
+                      </a:r>
+                      <a:endParaRPr lang="en-US" sz="1400" dirty="0"/>
+                    </a:p>
+                  </a:txBody>
+                  <a:tcPr marL="0" marR="0" marT="0" marB="0">
+                    <a:lnL w="0" cap="flat" cmpd="sng" algn="ctr">
+                      <a:noFill/>
+                    </a:lnL>
+                    <a:lnR w="0" cap="flat" cmpd="sng" algn="ctr">
+                      <a:noFill/>
+                    </a:lnR>
+                    <a:lnT w="0" cap="flat" cmpd="sng" algn="ctr">
+                      <a:noFill/>
+                    </a:lnT>
+                    <a:lnB w="0" cap="flat" cmpd="sng" algn="ctr">
+                      <a:noFill/>
+                    </a:lnB>
+                  </a:tcPr>
+                </a:tc>
+              </a:tr>
+              <a:tr h="384048">
+                <a:tc>
+                  <a:txBody>
+                    <a:bodyPr/>
+                    <a:lstStyle/>
+                    <a:p>
+                      <a:pPr indent="0" marL="0">
+                        <a:buNone/>
+                      </a:pPr>
+                      <a:r>
+                        <a:rPr lang="en-US" sz="1300" dirty="0">
+                          <a:solidFill>
+                            <a:srgbClr val="94A3B8"/>
+                          </a:solidFill>
+                        </a:rPr>
+                        <a:t>Matricule</a:t>
                       </a:r>
                       <a:endParaRPr lang="en-US" sz="1300" dirty="0"/>
                     </a:p>
@@ -3495,7 +3565,7 @@
       </p:graphicFrame>
       <p:sp>
         <p:nvSpPr>
-          <p:cNvPr id="9" name="Carte des membres"/>
+          <p:cNvPr id="9" name="Carte travail individuel"/>
           <p:cNvSpPr/>
           <p:nvPr/>
         </p:nvSpPr>
@@ -3522,14 +3592,63 @@
       </p:sp>
       <p:sp>
         <p:nvSpPr>
-          <p:cNvPr id="10" name="Text 5"/>
+          <p:cNvPr id="10" name="Pastille"/>
+          <p:cNvSpPr/>
+          <p:nvPr/>
+        </p:nvSpPr>
+        <p:spPr>
+          <a:xfrm>
+            <a:off x="7223760" y="777240"/>
+            <a:ext cx="640080" cy="640080"/>
+          </a:xfrm>
+          <a:prstGeom prst="ellipse">
+            <a:avLst/>
+          </a:prstGeom>
+          <a:solidFill>
+            <a:srgbClr val="B45309"/>
+          </a:solidFill>
+          <a:ln w="12700">
+            <a:solidFill>
+              <a:srgbClr val="B45309"/>
+            </a:solidFill>
+            <a:prstDash val="solid"/>
+          </a:ln>
+        </p:spPr>
+      </p:sp>
+      <p:pic>
+        <p:nvPicPr>
+          <p:cNvPr id="11" name="Icône LuUserCog" descr="preencoded.png">    </p:cNvPr>
+          <p:cNvPicPr>
+            <a:picLocks noChangeAspect="1"/>
+          </p:cNvPicPr>
+          <p:nvPr/>
+        </p:nvPicPr>
+        <p:blipFill>
+          <a:blip r:embed="rId2"/>
+          <a:stretch>
+            <a:fillRect/>
+          </a:stretch>
+        </p:blipFill>
+        <p:spPr>
+          <a:xfrm>
+            <a:off x="7364578" y="918058"/>
+            <a:ext cx="358445" cy="358445"/>
+          </a:xfrm>
+          <a:prstGeom prst="rect">
+            <a:avLst/>
+          </a:prstGeom>
+        </p:spPr>
+      </p:pic>
+      <p:sp>
+        <p:nvSpPr>
+          <p:cNvPr id="12" name="Text 6"/>
           <p:cNvSpPr txBox="1"/>
           <p:nvPr/>
         </p:nvSpPr>
         <p:spPr>
           <a:xfrm>
-            <a:off x="7223760" y="731520"/>
-            <a:ext cx="4206240" cy="411480"/>
+            <a:off x="8001000" y="777240"/>
+            <a:ext cx="3474720" cy="640080"/>
           </a:xfrm>
           <a:prstGeom prst="rect">
             <a:avLst/>
@@ -3545,31 +3664,67 @@
               <a:buNone/>
             </a:pPr>
             <a:r>
-              <a:rPr lang="en-US" sz="1800" b="1" dirty="0">
+              <a:rPr lang="en-US" sz="2000" b="1" dirty="0">
                 <a:solidFill>
                   <a:schemeClr val="bg1"/>
                 </a:solidFill>
               </a:rPr>
-              <a:t>Membres du groupe</a:t>
-            </a:r>
-            <a:endParaRPr lang="en-US" sz="1800" dirty="0"/>
+              <a:t>Travail individuel</a:t>
+            </a:r>
+            <a:endParaRPr lang="en-US" sz="2000" dirty="0"/>
           </a:p>
         </p:txBody>
       </p:sp>
       <p:sp>
         <p:nvSpPr>
-          <p:cNvPr id="11" name="Membre 1"/>
+          <p:cNvPr id="13" name="Text 7"/>
+          <p:cNvSpPr txBox="1"/>
+          <p:nvPr/>
+        </p:nvSpPr>
+        <p:spPr>
+          <a:xfrm>
+            <a:off x="7223760" y="1554480"/>
+            <a:ext cx="4206240" cy="685800"/>
+          </a:xfrm>
+          <a:prstGeom prst="rect">
+            <a:avLst/>
+          </a:prstGeom>
+          <a:noFill/>
+          <a:ln/>
+        </p:spPr>
+        <p:txBody>
+          <a:bodyPr wrap="square" lIns="0" tIns="0" rIns="0" bIns="0" rtlCol="0" anchor="t"/>
+          <a:lstStyle/>
+          <a:p>
+            <a:pPr indent="0" marL="0">
+              <a:buNone/>
+            </a:pPr>
+            <a:r>
+              <a:rPr lang="en-US" sz="1300" dirty="0">
+                <a:solidFill>
+                  <a:srgbClr val="CBD5E1"/>
+                </a:solidFill>
+              </a:rPr>
+              <a:t>Conception, développement, tests et rapport réalisés entièrement par l'auteur.</a:t>
+            </a:r>
+            <a:endParaRPr lang="en-US" sz="1300" dirty="0"/>
+          </a:p>
+        </p:txBody>
+      </p:sp>
+      <p:sp>
+        <p:nvSpPr>
+          <p:cNvPr id="14" name="Chiffre 1"/>
           <p:cNvSpPr/>
           <p:nvPr/>
         </p:nvSpPr>
         <p:spPr>
           <a:xfrm>
-            <a:off x="7223760" y="1325880"/>
-            <a:ext cx="4160520" cy="1051560"/>
+            <a:off x="7223760" y="2377440"/>
+            <a:ext cx="4160520" cy="822960"/>
           </a:xfrm>
           <a:prstGeom prst="roundRect">
             <a:avLst>
-              <a:gd name="adj" fmla="val 6957"/>
+              <a:gd name="adj" fmla="val 8889"/>
             </a:avLst>
           </a:prstGeom>
           <a:solidFill>
@@ -3585,14 +3740,14 @@
       </p:sp>
       <p:sp>
         <p:nvSpPr>
-          <p:cNvPr id="12" name="Text 7"/>
+          <p:cNvPr id="15" name="Text 9"/>
           <p:cNvSpPr txBox="1"/>
           <p:nvPr/>
         </p:nvSpPr>
         <p:spPr>
           <a:xfrm>
-            <a:off x="7406640" y="1399032"/>
-            <a:ext cx="3840480" cy="914400"/>
+            <a:off x="7406640" y="2377440"/>
+            <a:ext cx="3840480" cy="822960"/>
           </a:xfrm>
           <a:prstGeom prst="rect">
             <a:avLst/>
@@ -3608,59 +3763,42 @@
               <a:buNone/>
             </a:pPr>
             <a:r>
-              <a:rPr lang="en-US" sz="1400" b="1" dirty="0">
+              <a:rPr lang="en-US" sz="2600" b="1" dirty="0">
+                <a:solidFill>
+                  <a:srgbClr val="BFD0FA"/>
+                </a:solidFill>
+              </a:rPr>
+              <a:t>11</a:t>
+            </a:r>
+            <a:pPr indent="0" marL="0">
+              <a:buNone/>
+            </a:pPr>
+            <a:r>
+              <a:rPr lang="en-US" sz="1300" dirty="0">
                 <a:solidFill>
                   <a:srgbClr val="FFFFFF"/>
                 </a:solidFill>
               </a:rPr>
-              <a:t>NOM Prénom [À compléter]</a:t>
-            </a:r>
-            <a:endParaRPr lang="en-US" sz="1400" dirty="0"/>
-          </a:p>
-          <a:p>
-            <a:pPr indent="0" marL="0">
-              <a:buNone/>
-            </a:pPr>
-            <a:r>
-              <a:rPr lang="en-US" sz="1200" dirty="0">
-                <a:solidFill>
-                  <a:srgbClr val="CBD5E1"/>
-                </a:solidFill>
-              </a:rPr>
-              <a:t>Matricule : [À compléter]</a:t>
-            </a:r>
-            <a:endParaRPr lang="en-US" sz="1400" dirty="0"/>
-          </a:p>
-          <a:p>
-            <a:pPr indent="0" marL="0">
-              <a:buNone/>
-            </a:pPr>
-            <a:r>
-              <a:rPr lang="en-US" sz="1200" dirty="0">
-                <a:solidFill>
-                  <a:srgbClr val="BFD0FA"/>
-                </a:solidFill>
-              </a:rPr>
-              <a:t>Rôle : Base de données et données de test</a:t>
-            </a:r>
-            <a:endParaRPr lang="en-US" sz="1400" dirty="0"/>
+              <a:t>   étapes, chacune avec sa spec et son plan</a:t>
+            </a:r>
+            <a:endParaRPr lang="en-US" sz="2600" dirty="0"/>
           </a:p>
         </p:txBody>
       </p:sp>
       <p:sp>
         <p:nvSpPr>
-          <p:cNvPr id="13" name="Membre 2"/>
+          <p:cNvPr id="16" name="Chiffre 2"/>
           <p:cNvSpPr/>
           <p:nvPr/>
         </p:nvSpPr>
         <p:spPr>
           <a:xfrm>
-            <a:off x="7223760" y="2532888"/>
-            <a:ext cx="4160520" cy="1051560"/>
+            <a:off x="7223760" y="3337560"/>
+            <a:ext cx="4160520" cy="822960"/>
           </a:xfrm>
           <a:prstGeom prst="roundRect">
             <a:avLst>
-              <a:gd name="adj" fmla="val 6957"/>
+              <a:gd name="adj" fmla="val 8889"/>
             </a:avLst>
           </a:prstGeom>
           <a:solidFill>
@@ -3676,14 +3814,14 @@
       </p:sp>
       <p:sp>
         <p:nvSpPr>
-          <p:cNvPr id="14" name="Text 9"/>
+          <p:cNvPr id="17" name="Text 11"/>
           <p:cNvSpPr txBox="1"/>
           <p:nvPr/>
         </p:nvSpPr>
         <p:spPr>
           <a:xfrm>
-            <a:off x="7406640" y="2606040"/>
-            <a:ext cx="3840480" cy="914400"/>
+            <a:off x="7406640" y="3337560"/>
+            <a:ext cx="3840480" cy="822960"/>
           </a:xfrm>
           <a:prstGeom prst="rect">
             <a:avLst/>
@@ -3699,59 +3837,42 @@
               <a:buNone/>
             </a:pPr>
             <a:r>
-              <a:rPr lang="en-US" sz="1400" b="1" dirty="0">
+              <a:rPr lang="en-US" sz="2600" b="1" dirty="0">
+                <a:solidFill>
+                  <a:srgbClr val="BFD0FA"/>
+                </a:solidFill>
+              </a:rPr>
+              <a:t>34</a:t>
+            </a:r>
+            <a:pPr indent="0" marL="0">
+              <a:buNone/>
+            </a:pPr>
+            <a:r>
+              <a:rPr lang="en-US" sz="1300" dirty="0">
                 <a:solidFill>
                   <a:srgbClr val="FFFFFF"/>
                 </a:solidFill>
               </a:rPr>
-              <a:t>NOM Prénom [À compléter]</a:t>
-            </a:r>
-            <a:endParaRPr lang="en-US" sz="1400" dirty="0"/>
-          </a:p>
-          <a:p>
-            <a:pPr indent="0" marL="0">
-              <a:buNone/>
-            </a:pPr>
-            <a:r>
-              <a:rPr lang="en-US" sz="1200" dirty="0">
-                <a:solidFill>
-                  <a:srgbClr val="CBD5E1"/>
-                </a:solidFill>
-              </a:rPr>
-              <a:t>Matricule : [À compléter]</a:t>
-            </a:r>
-            <a:endParaRPr lang="en-US" sz="1400" dirty="0"/>
-          </a:p>
-          <a:p>
-            <a:pPr indent="0" marL="0">
-              <a:buNone/>
-            </a:pPr>
-            <a:r>
-              <a:rPr lang="en-US" sz="1200" dirty="0">
-                <a:solidFill>
-                  <a:srgbClr val="BFD0FA"/>
-                </a:solidFill>
-              </a:rPr>
-              <a:t>Rôle : Gabarits HTML et CSS</a:t>
-            </a:r>
-            <a:endParaRPr lang="en-US" sz="1400" dirty="0"/>
+              <a:t>   routes Flask, dont 3 API JSON</a:t>
+            </a:r>
+            <a:endParaRPr lang="en-US" sz="2600" dirty="0"/>
           </a:p>
         </p:txBody>
       </p:sp>
       <p:sp>
         <p:nvSpPr>
-          <p:cNvPr id="15" name="Membre 3"/>
+          <p:cNvPr id="18" name="Chiffre 3"/>
           <p:cNvSpPr/>
           <p:nvPr/>
         </p:nvSpPr>
         <p:spPr>
           <a:xfrm>
-            <a:off x="7223760" y="3739896"/>
-            <a:ext cx="4160520" cy="1051560"/>
+            <a:off x="7223760" y="4297680"/>
+            <a:ext cx="4160520" cy="822960"/>
           </a:xfrm>
           <a:prstGeom prst="roundRect">
             <a:avLst>
-              <a:gd name="adj" fmla="val 6957"/>
+              <a:gd name="adj" fmla="val 8889"/>
             </a:avLst>
           </a:prstGeom>
           <a:solidFill>
@@ -3767,14 +3888,14 @@
       </p:sp>
       <p:sp>
         <p:nvSpPr>
-          <p:cNvPr id="16" name="Text 11"/>
+          <p:cNvPr id="19" name="Text 13"/>
           <p:cNvSpPr txBox="1"/>
           <p:nvPr/>
         </p:nvSpPr>
         <p:spPr>
           <a:xfrm>
-            <a:off x="7406640" y="3813048"/>
-            <a:ext cx="3840480" cy="914400"/>
+            <a:off x="7406640" y="4297680"/>
+            <a:ext cx="3840480" cy="822960"/>
           </a:xfrm>
           <a:prstGeom prst="rect">
             <a:avLst/>
@@ -3790,59 +3911,42 @@
               <a:buNone/>
             </a:pPr>
             <a:r>
-              <a:rPr lang="en-US" sz="1400" b="1" dirty="0">
+              <a:rPr lang="en-US" sz="2600" b="1" dirty="0">
+                <a:solidFill>
+                  <a:srgbClr val="BFD0FA"/>
+                </a:solidFill>
+              </a:rPr>
+              <a:t>84</a:t>
+            </a:r>
+            <a:pPr indent="0" marL="0">
+              <a:buNone/>
+            </a:pPr>
+            <a:r>
+              <a:rPr lang="en-US" sz="1300" dirty="0">
                 <a:solidFill>
                   <a:srgbClr val="FFFFFF"/>
                 </a:solidFill>
               </a:rPr>
-              <a:t>NOM Prénom [À compléter]</a:t>
-            </a:r>
-            <a:endParaRPr lang="en-US" sz="1400" dirty="0"/>
-          </a:p>
-          <a:p>
-            <a:pPr indent="0" marL="0">
-              <a:buNone/>
-            </a:pPr>
-            <a:r>
-              <a:rPr lang="en-US" sz="1200" dirty="0">
-                <a:solidFill>
-                  <a:srgbClr val="CBD5E1"/>
-                </a:solidFill>
-              </a:rPr>
-              <a:t>Matricule : [À compléter]</a:t>
-            </a:r>
-            <a:endParaRPr lang="en-US" sz="1400" dirty="0"/>
-          </a:p>
-          <a:p>
-            <a:pPr indent="0" marL="0">
-              <a:buNone/>
-            </a:pPr>
-            <a:r>
-              <a:rPr lang="en-US" sz="1200" dirty="0">
-                <a:solidFill>
-                  <a:srgbClr val="BFD0FA"/>
-                </a:solidFill>
-              </a:rPr>
-              <a:t>Rôle : Routes Flask et sécurité</a:t>
-            </a:r>
-            <a:endParaRPr lang="en-US" sz="1400" dirty="0"/>
+              <a:t>   tests automatiques réussis</a:t>
+            </a:r>
+            <a:endParaRPr lang="en-US" sz="2600" dirty="0"/>
           </a:p>
         </p:txBody>
       </p:sp>
       <p:sp>
         <p:nvSpPr>
-          <p:cNvPr id="17" name="Membre 4"/>
+          <p:cNvPr id="20" name="Chiffre 4"/>
           <p:cNvSpPr/>
           <p:nvPr/>
         </p:nvSpPr>
         <p:spPr>
           <a:xfrm>
-            <a:off x="7223760" y="4946904"/>
-            <a:ext cx="4160520" cy="1051560"/>
+            <a:off x="7223760" y="5257800"/>
+            <a:ext cx="4160520" cy="822960"/>
           </a:xfrm>
           <a:prstGeom prst="roundRect">
             <a:avLst>
-              <a:gd name="adj" fmla="val 6957"/>
+              <a:gd name="adj" fmla="val 8889"/>
             </a:avLst>
           </a:prstGeom>
           <a:solidFill>
@@ -3858,14 +3962,14 @@
       </p:sp>
       <p:sp>
         <p:nvSpPr>
-          <p:cNvPr id="18" name="Text 13"/>
+          <p:cNvPr id="21" name="Text 15"/>
           <p:cNvSpPr txBox="1"/>
           <p:nvPr/>
         </p:nvSpPr>
         <p:spPr>
           <a:xfrm>
-            <a:off x="7406640" y="5020056"/>
-            <a:ext cx="3840480" cy="914400"/>
+            <a:off x="7406640" y="5257800"/>
+            <a:ext cx="3840480" cy="822960"/>
           </a:xfrm>
           <a:prstGeom prst="rect">
             <a:avLst/>
@@ -3881,42 +3985,25 @@
               <a:buNone/>
             </a:pPr>
             <a:r>
-              <a:rPr lang="en-US" sz="1400" b="1" dirty="0">
+              <a:rPr lang="en-US" sz="2600" b="1" dirty="0">
+                <a:solidFill>
+                  <a:srgbClr val="BFD0FA"/>
+                </a:solidFill>
+              </a:rPr>
+              <a:t>0</a:t>
+            </a:r>
+            <a:pPr indent="0" marL="0">
+              <a:buNone/>
+            </a:pPr>
+            <a:r>
+              <a:rPr lang="en-US" sz="1300" dirty="0">
                 <a:solidFill>
                   <a:srgbClr val="FFFFFF"/>
                 </a:solidFill>
               </a:rPr>
-              <a:t>NOM Prénom [À compléter]</a:t>
-            </a:r>
-            <a:endParaRPr lang="en-US" sz="1400" dirty="0"/>
-          </a:p>
-          <a:p>
-            <a:pPr indent="0" marL="0">
-              <a:buNone/>
-            </a:pPr>
-            <a:r>
-              <a:rPr lang="en-US" sz="1200" dirty="0">
-                <a:solidFill>
-                  <a:srgbClr val="CBD5E1"/>
-                </a:solidFill>
-              </a:rPr>
-              <a:t>Matricule : [À compléter]</a:t>
-            </a:r>
-            <a:endParaRPr lang="en-US" sz="1400" dirty="0"/>
-          </a:p>
-          <a:p>
-            <a:pPr indent="0" marL="0">
-              <a:buNone/>
-            </a:pPr>
-            <a:r>
-              <a:rPr lang="en-US" sz="1200" dirty="0">
-                <a:solidFill>
-                  <a:srgbClr val="BFD0FA"/>
-                </a:solidFill>
-              </a:rPr>
-              <a:t>Rôle : JavaScript, API et graphiques</a:t>
-            </a:r>
-            <a:endParaRPr lang="en-US" sz="1400" dirty="0"/>
+              <a:t>   erreur au validateur HTML</a:t>
+            </a:r>
+            <a:endParaRPr lang="en-US" sz="2600" dirty="0"/>
           </a:p>
         </p:txBody>
       </p:sp>
@@ -8993,7 +9080,7 @@
                   <a:schemeClr val="tx1"/>
                 </a:solidFill>
               </a:rPr>
-              <a:t>Répartition du travail</a:t>
+              <a:t>Organisation du travail personnel</a:t>
             </a:r>
             <a:endParaRPr lang="en-US" sz="3000" dirty="0"/>
           </a:p>
@@ -9001,7 +9088,7 @@
       </p:sp>
       <p:graphicFrame>
         <p:nvGraphicFramePr>
-          <p:cNvPr id="20" name="Tableau de répartition"/>
+          <p:cNvPr id="20" name="Tableau d'organisation"/>
           <p:cNvGraphicFramePr>
             <a:graphicFrameLocks noGrp="1"/>
           </p:cNvGraphicFramePr>
@@ -9022,10 +9109,10 @@
             <a:tbl>
               <a:tblPr/>
               <a:tblGrid>
-                <a:gridCol w="2377440"/>
-                <a:gridCol w="4023360"/>
+                <a:gridCol w="1920240"/>
+                <a:gridCol w="4480560"/>
               </a:tblGrid>
-              <a:tr h="685800">
+              <a:tr h="777240">
                 <a:tc>
                   <a:txBody>
                     <a:bodyPr/>
@@ -9040,7 +9127,7 @@
                             <a:srgbClr val="FFFFFF"/>
                           </a:solidFill>
                         </a:rPr>
-                        <a:t>Membre</a:t>
+                        <a:t>Phase</a:t>
                       </a:r>
                       <a:endParaRPr lang="en-US" sz="1300" dirty="0"/>
                     </a:p>
@@ -9149,7 +9236,7 @@
                   </a:tcPr>
                 </a:tc>
               </a:tr>
-              <a:tr h="685800">
+              <a:tr h="777240">
                 <a:tc>
                   <a:txBody>
                     <a:bodyPr/>
@@ -9164,7 +9251,7 @@
                             <a:srgbClr val="0F172A"/>
                           </a:solidFill>
                         </a:rPr>
-                        <a:t>Membre 1 [À compléter]</a:t>
+                        <a:t>Analyse</a:t>
                       </a:r>
                       <a:endParaRPr lang="en-US" sz="1300" dirty="0"/>
                     </a:p>
@@ -9225,7 +9312,7 @@
                             <a:srgbClr val="0F172A"/>
                           </a:solidFill>
                         </a:rPr>
-                        <a:t>schema.sql, donnees_test.py, export, calculs des moyennes</a:t>
+                        <a:t>cahier des charges : toutes les exigences numérotées, hypothèses de conception</a:t>
                       </a:r>
                       <a:endParaRPr lang="en-US" sz="1300" dirty="0"/>
                     </a:p>
@@ -9273,7 +9360,7 @@
                   </a:tcPr>
                 </a:tc>
               </a:tr>
-              <a:tr h="685800">
+              <a:tr h="777240">
                 <a:tc>
                   <a:txBody>
                     <a:bodyPr/>
@@ -9288,7 +9375,7 @@
                             <a:srgbClr val="0F172A"/>
                           </a:solidFill>
                         </a:rPr>
-                        <a:t>Membre 2 [À compléter]</a:t>
+                        <a:t>Conception</a:t>
                       </a:r>
                       <a:endParaRPr lang="en-US" sz="1300" dirty="0"/>
                     </a:p>
@@ -9349,7 +9436,7 @@
                             <a:srgbClr val="0F172A"/>
                           </a:solidFill>
                         </a:rPr>
-                        <a:t>base.html, gabarits Jinja2, style.css, impression, accessibilité</a:t>
+                        <a:t>maquettes des 11 écrans, schéma de la base, liste des routes</a:t>
                       </a:r>
                       <a:endParaRPr lang="en-US" sz="1300" dirty="0"/>
                     </a:p>
@@ -9397,7 +9484,7 @@
                   </a:tcPr>
                 </a:tc>
               </a:tr>
-              <a:tr h="685800">
+              <a:tr h="777240">
                 <a:tc>
                   <a:txBody>
                     <a:bodyPr/>
@@ -9412,7 +9499,7 @@
                             <a:srgbClr val="0F172A"/>
                           </a:solidFill>
                         </a:rPr>
-                        <a:t>Membre 3 [À compléter]</a:t>
+                        <a:t>Développement</a:t>
                       </a:r>
                       <a:endParaRPr lang="en-US" sz="1300" dirty="0"/>
                     </a:p>
@@ -9473,7 +9560,7 @@
                             <a:srgbClr val="0F172A"/>
                           </a:solidFill>
                         </a:rPr>
-                        <a:t>routes Flask, connexion, droits, saisie, import</a:t>
+                        <a:t>11 étapes : base, gabarits, calculs, connexion, bulletin, saisie, listes, statistiques, administration, import, finitions</a:t>
                       </a:r>
                       <a:endParaRPr lang="en-US" sz="1300" dirty="0"/>
                     </a:p>
@@ -9521,7 +9608,7 @@
                   </a:tcPr>
                 </a:tc>
               </a:tr>
-              <a:tr h="685800">
+              <a:tr h="777240">
                 <a:tc>
                   <a:txBody>
                     <a:bodyPr/>
@@ -9536,7 +9623,7 @@
                             <a:srgbClr val="0F172A"/>
                           </a:solidFill>
                         </a:rPr>
-                        <a:t>Membre 4 [À compléter]</a:t>
+                        <a:t>Tests et qualité</a:t>
                       </a:r>
                       <a:endParaRPr lang="en-US" sz="1300" dirty="0"/>
                     </a:p>
@@ -9597,7 +9684,7 @@
                             <a:srgbClr val="0F172A"/>
                           </a:solidFill>
                         </a:rPr>
-                        <a:t>validation.js, saisie en direct, fetch, Chart.js, statistiques</a:t>
+                        <a:t>84 tests automatiques, validateur HTML, accessibilité, téléphone</a:t>
                       </a:r>
                       <a:endParaRPr lang="en-US" sz="1300" dirty="0"/>
                     </a:p>
@@ -9645,7 +9732,7 @@
                   </a:tcPr>
                 </a:tc>
               </a:tr>
-              <a:tr h="685800">
+              <a:tr h="777240">
                 <a:tc>
                   <a:txBody>
                     <a:bodyPr/>
@@ -9660,7 +9747,7 @@
                             <a:srgbClr val="0F172A"/>
                           </a:solidFill>
                         </a:rPr>
-                        <a:t>Tous</a:t>
+                        <a:t>Rendu</a:t>
                       </a:r>
                       <a:endParaRPr lang="en-US" sz="1300" dirty="0"/>
                     </a:p>
@@ -9702,6 +9789,9 @@
                       <a:headEnd type="none" w="med" len="med"/>
                       <a:tailEnd type="none" w="med" len="med"/>
                     </a:lnB>
+                    <a:solidFill>
+                      <a:srgbClr val="F1F5F9"/>
+                    </a:solidFill>
                   </a:tcPr>
                 </a:tc>
                 <a:tc>
@@ -9718,7 +9808,7 @@
                             <a:srgbClr val="0F172A"/>
                           </a:solidFill>
                         </a:rPr>
-                        <a:t>relecture croisée, tests, captures, rapport et vidéo</a:t>
+                        <a:t>README, base remplie et export SQL, captures, rapport et vidéo</a:t>
                       </a:r>
                       <a:endParaRPr lang="en-US" sz="1300" dirty="0"/>
                     </a:p>
@@ -9760,6 +9850,9 @@
                       <a:headEnd type="none" w="med" len="med"/>
                       <a:tailEnd type="none" w="med" len="med"/>
                     </a:lnB>
+                    <a:solidFill>
+                      <a:srgbClr val="F1F5F9"/>
+                    </a:solidFill>
                   </a:tcPr>
                 </a:tc>
               </a:tr>
@@ -9824,7 +9917,7 @@
                   <a:schemeClr val="tx1"/>
                 </a:solidFill>
               </a:rPr>
-              <a:t>Méthode : 11 étapes</a:t>
+              <a:t>Développement : 11 étapes</a:t>
             </a:r>
             <a:endParaRPr lang="en-US" sz="1700" dirty="0"/>
           </a:p>
@@ -11180,7 +11273,7 @@
                   <a:schemeClr val="accent1"/>
                 </a:solidFill>
               </a:rPr>
-              <a:t>Notre réponse</a:t>
+              <a:t>La réponse apportée</a:t>
             </a:r>
             <a:endParaRPr lang="en-US" sz="1400" dirty="0"/>
           </a:p>

</xml_diff>